<commit_message>
Finished Audio input website
</commit_message>
<xml_diff>
--- a/website_structure.pptx
+++ b/website_structure.pptx
@@ -104,6 +104,11 @@
       </a:defRPr>
     </a:lvl9pPr>
   </p:defaultTextStyle>
+  <p:extLst>
+    <p:ext uri="{EFAFB233-063F-42B5-8137-9DF3F51BA10A}">
+      <p15:sldGuideLst xmlns:p15="http://schemas.microsoft.com/office/powerpoint/2012/main"/>
+    </p:ext>
+  </p:extLst>
 </p:presentation>
 </file>
 
@@ -254,7 +259,7 @@
           <a:p>
             <a:fld id="{6F032055-4BD4-4B45-BB1B-191EE6E37A63}" type="datetimeFigureOut">
               <a:rPr lang="de-DE" smtClean="0"/>
-              <a:t>13.08.2026</a:t>
+              <a:t>26.08.2026</a:t>
             </a:fld>
             <a:endParaRPr lang="de-DE"/>
           </a:p>
@@ -452,7 +457,7 @@
           <a:p>
             <a:fld id="{6F032055-4BD4-4B45-BB1B-191EE6E37A63}" type="datetimeFigureOut">
               <a:rPr lang="de-DE" smtClean="0"/>
-              <a:t>13.08.2026</a:t>
+              <a:t>26.08.2026</a:t>
             </a:fld>
             <a:endParaRPr lang="de-DE"/>
           </a:p>
@@ -660,7 +665,7 @@
           <a:p>
             <a:fld id="{6F032055-4BD4-4B45-BB1B-191EE6E37A63}" type="datetimeFigureOut">
               <a:rPr lang="de-DE" smtClean="0"/>
-              <a:t>13.08.2026</a:t>
+              <a:t>26.08.2026</a:t>
             </a:fld>
             <a:endParaRPr lang="de-DE"/>
           </a:p>
@@ -858,7 +863,7 @@
           <a:p>
             <a:fld id="{6F032055-4BD4-4B45-BB1B-191EE6E37A63}" type="datetimeFigureOut">
               <a:rPr lang="de-DE" smtClean="0"/>
-              <a:t>13.08.2026</a:t>
+              <a:t>26.08.2026</a:t>
             </a:fld>
             <a:endParaRPr lang="de-DE"/>
           </a:p>
@@ -1133,7 +1138,7 @@
           <a:p>
             <a:fld id="{6F032055-4BD4-4B45-BB1B-191EE6E37A63}" type="datetimeFigureOut">
               <a:rPr lang="de-DE" smtClean="0"/>
-              <a:t>13.08.2026</a:t>
+              <a:t>26.08.2026</a:t>
             </a:fld>
             <a:endParaRPr lang="de-DE"/>
           </a:p>
@@ -1398,7 +1403,7 @@
           <a:p>
             <a:fld id="{6F032055-4BD4-4B45-BB1B-191EE6E37A63}" type="datetimeFigureOut">
               <a:rPr lang="de-DE" smtClean="0"/>
-              <a:t>13.08.2026</a:t>
+              <a:t>26.08.2026</a:t>
             </a:fld>
             <a:endParaRPr lang="de-DE"/>
           </a:p>
@@ -1810,7 +1815,7 @@
           <a:p>
             <a:fld id="{6F032055-4BD4-4B45-BB1B-191EE6E37A63}" type="datetimeFigureOut">
               <a:rPr lang="de-DE" smtClean="0"/>
-              <a:t>13.08.2026</a:t>
+              <a:t>26.08.2026</a:t>
             </a:fld>
             <a:endParaRPr lang="de-DE"/>
           </a:p>
@@ -1951,7 +1956,7 @@
           <a:p>
             <a:fld id="{6F032055-4BD4-4B45-BB1B-191EE6E37A63}" type="datetimeFigureOut">
               <a:rPr lang="de-DE" smtClean="0"/>
-              <a:t>13.08.2026</a:t>
+              <a:t>26.08.2026</a:t>
             </a:fld>
             <a:endParaRPr lang="de-DE"/>
           </a:p>
@@ -2064,7 +2069,7 @@
           <a:p>
             <a:fld id="{6F032055-4BD4-4B45-BB1B-191EE6E37A63}" type="datetimeFigureOut">
               <a:rPr lang="de-DE" smtClean="0"/>
-              <a:t>13.08.2026</a:t>
+              <a:t>26.08.2026</a:t>
             </a:fld>
             <a:endParaRPr lang="de-DE"/>
           </a:p>
@@ -2375,7 +2380,7 @@
           <a:p>
             <a:fld id="{6F032055-4BD4-4B45-BB1B-191EE6E37A63}" type="datetimeFigureOut">
               <a:rPr lang="de-DE" smtClean="0"/>
-              <a:t>13.08.2026</a:t>
+              <a:t>26.08.2026</a:t>
             </a:fld>
             <a:endParaRPr lang="de-DE"/>
           </a:p>
@@ -2663,7 +2668,7 @@
           <a:p>
             <a:fld id="{6F032055-4BD4-4B45-BB1B-191EE6E37A63}" type="datetimeFigureOut">
               <a:rPr lang="de-DE" smtClean="0"/>
-              <a:t>13.08.2026</a:t>
+              <a:t>26.08.2026</a:t>
             </a:fld>
             <a:endParaRPr lang="de-DE"/>
           </a:p>
@@ -2904,7 +2909,7 @@
           <a:p>
             <a:fld id="{6F032055-4BD4-4B45-BB1B-191EE6E37A63}" type="datetimeFigureOut">
               <a:rPr lang="de-DE" smtClean="0"/>
-              <a:t>13.08.2026</a:t>
+              <a:t>26.08.2026</a:t>
             </a:fld>
             <a:endParaRPr lang="de-DE"/>
           </a:p>
@@ -4390,6 +4395,96 @@
             <a:r>
               <a:rPr lang="de-DE" dirty="0"/>
               <a:t>Nicht alles durchlaufen, sondern bis Nutzer abbricht</a:t>
+            </a:r>
+          </a:p>
+        </p:txBody>
+      </p:sp>
+      <p:sp>
+        <p:nvSpPr>
+          <p:cNvPr id="3" name="Textfeld 2">
+            <a:extLst>
+              <a:ext uri="{FF2B5EF4-FFF2-40B4-BE49-F238E27FC236}">
+                <a16:creationId xmlns:a16="http://schemas.microsoft.com/office/drawing/2014/main" id="{E01E05C4-C436-D32D-7EEA-A26D8C500B83}"/>
+              </a:ext>
+            </a:extLst>
+          </p:cNvPr>
+          <p:cNvSpPr txBox="1"/>
+          <p:nvPr/>
+        </p:nvSpPr>
+        <p:spPr>
+          <a:xfrm>
+            <a:off x="61384" y="2575409"/>
+            <a:ext cx="1782232" cy="369332"/>
+          </a:xfrm>
+          <a:prstGeom prst="rect">
+            <a:avLst/>
+          </a:prstGeom>
+          <a:solidFill>
+            <a:schemeClr val="bg1">
+              <a:lumMod val="85000"/>
+            </a:schemeClr>
+          </a:solidFill>
+          <a:ln>
+            <a:solidFill>
+              <a:schemeClr val="tx1"/>
+            </a:solidFill>
+          </a:ln>
+        </p:spPr>
+        <p:txBody>
+          <a:bodyPr wrap="square" rtlCol="0">
+            <a:spAutoFit/>
+          </a:bodyPr>
+          <a:lstStyle/>
+          <a:p>
+            <a:pPr algn="ctr"/>
+            <a:r>
+              <a:rPr lang="de-DE" dirty="0"/>
+              <a:t>Skip</a:t>
+            </a:r>
+          </a:p>
+        </p:txBody>
+      </p:sp>
+      <p:sp>
+        <p:nvSpPr>
+          <p:cNvPr id="7" name="Textfeld 6">
+            <a:extLst>
+              <a:ext uri="{FF2B5EF4-FFF2-40B4-BE49-F238E27FC236}">
+                <a16:creationId xmlns:a16="http://schemas.microsoft.com/office/drawing/2014/main" id="{CB6BAFC0-0B7D-B293-C265-8D67E1C85587}"/>
+              </a:ext>
+            </a:extLst>
+          </p:cNvPr>
+          <p:cNvSpPr txBox="1"/>
+          <p:nvPr/>
+        </p:nvSpPr>
+        <p:spPr>
+          <a:xfrm>
+            <a:off x="74084" y="3379026"/>
+            <a:ext cx="1782232" cy="369332"/>
+          </a:xfrm>
+          <a:prstGeom prst="rect">
+            <a:avLst/>
+          </a:prstGeom>
+          <a:solidFill>
+            <a:schemeClr val="bg1">
+              <a:lumMod val="85000"/>
+            </a:schemeClr>
+          </a:solidFill>
+          <a:ln>
+            <a:solidFill>
+              <a:schemeClr val="tx1"/>
+            </a:solidFill>
+          </a:ln>
+        </p:spPr>
+        <p:txBody>
+          <a:bodyPr wrap="square" rtlCol="0">
+            <a:spAutoFit/>
+          </a:bodyPr>
+          <a:lstStyle/>
+          <a:p>
+            <a:pPr algn="ctr"/>
+            <a:r>
+              <a:rPr lang="de-DE" dirty="0"/>
+              <a:t>Tupel</a:t>
             </a:r>
           </a:p>
         </p:txBody>

</xml_diff>